<commit_message>
feat: lock the 7-day kit to owning a car
Rewrite the deck, journal, and tracker around one desire: kendi arabam. Adds a ready 369 line, a driving SATS scene, and daily real-world car steps (budget, listings, insurance, deposit).

Co-authored-by: iremalisan <iremalisan@users.noreply.github.com>
</commit_message>
<xml_diff>
--- a/rehber/Hizli_Manifest_Teknikleri.pptx
+++ b/rehber/Hizli_Manifest_Teknikleri.pptx
@@ -3332,14 +3332,14 @@
           <a:p>
             <a:pPr algn="l"/>
             <a:r>
-              <a:rPr sz="4000" b="1" i="0">
+              <a:rPr sz="3800" b="1" i="0">
                 <a:solidFill>
                   <a:srgbClr val="FFFFFF"/>
                 </a:solidFill>
                 <a:latin typeface="Calibri"/>
               </a:rPr>
-              <a:t>7 günde hızlı
-manifest teknikleri</a:t>
+              <a:t>Kendi arabam
+için 7 günlük manifest</a:t>
             </a:r>
           </a:p>
         </p:txBody>
@@ -3374,8 +3374,8 @@
                 </a:solidFill>
                 <a:latin typeface="Calibri"/>
               </a:rPr>
-              <a:t>Tek istek seç. Aynı cümleyi 3-6-9 yaz. Gece olmuş gibi uyu.
-Gündüz bir somut adım at. Hız buradan gelir.</a:t>
+              <a:t>Cümleyi yaz. Direksiyonda uyu. Gündüz bir araba adımı at.
+Bu 7 günün tek isteği: kendi araban.</a:t>
             </a:r>
           </a:p>
         </p:txBody>
@@ -3455,7 +3455,7 @@
                 </a:solidFill>
                 <a:latin typeface="Calibri"/>
               </a:rPr>
-              <a:t>Hedef: 7 gün sonra otomatik alışkanlık</a:t>
+              <a:t>Kilit cümle: kendi arabamla yola çıkıyorum</a:t>
             </a:r>
           </a:p>
         </p:txBody>
@@ -4206,7 +4206,7 @@
                 </a:solidFill>
                 <a:latin typeface="Calibri"/>
               </a:rPr>
-              <a:t>Çok dilek</a:t>
+              <a:t>20 model</a:t>
             </a:r>
           </a:p>
         </p:txBody>
@@ -4241,7 +4241,7 @@
                 </a:solidFill>
                 <a:latin typeface="Calibri"/>
               </a:rPr>
-              <a:t>Aynı hafta para, ilişki, ev, iş. Birini seç.</a:t>
+              <a:t>Her gün başka araba. En fazla 3 aday, sonra 1–2.</a:t>
             </a:r>
           </a:p>
         </p:txBody>
@@ -4356,7 +4356,7 @@
                 </a:solidFill>
                 <a:latin typeface="Calibri"/>
               </a:rPr>
-              <a:t>‘Olacak’ cümlesi isteği sürekli yarına iter.</a:t>
+              <a:t>‘Araba olacak’ cümlesi anahtarı yarına iter.</a:t>
             </a:r>
           </a:p>
         </p:txBody>
@@ -4436,7 +4436,7 @@
                 </a:solidFill>
                 <a:latin typeface="Calibri"/>
               </a:rPr>
-              <a:t>Kanıt avı</a:t>
+              <a:t>İlan avı</a:t>
             </a:r>
           </a:p>
         </p:txBody>
@@ -4471,7 +4471,7 @@
                 </a:solidFill>
                 <a:latin typeface="Calibri"/>
               </a:rPr>
-              <a:t>Her saat ‘geldi mi’ diye bakmak, yokluk hissini büyütür.</a:t>
+              <a:t>Saatlerce bakıp hiçbirini aramamak yokluk hissini büyütür.</a:t>
             </a:r>
           </a:p>
         </p:txBody>
@@ -4551,7 +4551,7 @@
                 </a:solidFill>
                 <a:latin typeface="Calibri"/>
               </a:rPr>
-              <a:t>Başkasını zorlamak</a:t>
+              <a:t>Mucize peşinat</a:t>
             </a:r>
           </a:p>
         </p:txBody>
@@ -4586,7 +4586,7 @@
                 </a:solidFill>
                 <a:latin typeface="Calibri"/>
               </a:rPr>
-              <a:t>Birinin seni seçmesini dayatmak. Serbest, karşılıklı hali iste.</a:t>
+              <a:t>Birinin sana almasını beklemek. Senin adımın: biriktir / kredi / 2. el.</a:t>
             </a:r>
           </a:p>
         </p:txBody>
@@ -4701,7 +4701,7 @@
                 </a:solidFill>
                 <a:latin typeface="Calibri"/>
               </a:rPr>
-              <a:t>Gündüz sıfır adım. WOOP atlanmış demektir.</a:t>
+              <a:t>Direksiyon sahnesi var, galeri yok. WOOP atlanmış demektir.</a:t>
             </a:r>
           </a:p>
         </p:txBody>
@@ -4781,7 +4781,7 @@
                 </a:solidFill>
                 <a:latin typeface="Calibri"/>
               </a:rPr>
-              <a:t>Teknik koleksiyonu</a:t>
+              <a:t>Lüks eşiği</a:t>
             </a:r>
           </a:p>
         </p:txBody>
@@ -4816,7 +4816,7 @@
                 </a:solidFill>
                 <a:latin typeface="Calibri"/>
               </a:rPr>
-              <a:t>Her gün yeni yöntem. 7 gün aynı protokol.</a:t>
+              <a:t>Cümle alay ettiriyorsa önce sahibinden 2. el, sonra yükselt.</a:t>
             </a:r>
           </a:p>
         </p:txBody>
@@ -4896,7 +4896,7 @@
                 </a:solidFill>
                 <a:latin typeface="Calibri"/>
               </a:rPr>
-              <a:t>İnanç eşiğini aşmak</a:t>
+              <a:t>Teknik koleksiyonu</a:t>
             </a:r>
           </a:p>
         </p:txBody>
@@ -4931,7 +4931,7 @@
                 </a:solidFill>
                 <a:latin typeface="Calibri"/>
               </a:rPr>
-              <a:t>Cümle alay ettiriyorsa küçült. İnanılır gerilim kalsın.</a:t>
+              <a:t>Her gün yeni yöntem. 7 gün aynı araba protokolü.</a:t>
             </a:r>
           </a:p>
         </p:txBody>
@@ -4966,7 +4966,7 @@
                 </a:solidFill>
                 <a:latin typeface="Calibri"/>
               </a:rPr>
-              <a:t>7 günde hızlı manifest  •  tek istek  •  369 + SATS + WOOP  •  her gün 1 somut adım</a:t>
+              <a:t>Kendi arabam  •  369 + SATS + WOOP  •  her gün 1 araba adımı</a:t>
             </a:r>
           </a:p>
         </p:txBody>
@@ -5413,10 +5413,10 @@
                 </a:solidFill>
                 <a:latin typeface="Calibri"/>
               </a:rPr>
-              <a:t>• Neville Goddard — Feeling is the Secret (kısa, SATS’ın kaynağı)
-• Neville — The Power of Awareness (kimlik / varsayım)
-• woopmylife.org — WOOP’u 5 dakikada öğren
-• Gollwitzer: “eğer-o zaman” planları (uygulama niyeti)</a:t>
+              <a:t>• Neville — Feeling is the Secret (SATS)
+• 369 cümlesi: kendi arabamla yola çıkıyorum
+• woopmylife.org — para korkusunu plana bağla
+• Sahibinden / galeri: 3 aday, gerçek fiyat</a:t>
             </a:r>
           </a:p>
         </p:txBody>
@@ -5531,10 +5531,10 @@
                 </a:solidFill>
                 <a:latin typeface="Calibri"/>
               </a:rPr>
-              <a:t>• Neville — The Law and the Promise (örnek hikâyeler)
-• Gabriele Oettingen — Rethinking Positive Thinking
-• James Clear — Atomic Habits (küçük günlük adım)
-• r/NevilleGoddard — dikkat: başarı hikâyesi bağımlılığı yapma</a:t>
+              <a:t>• The Power of Awareness (sürücü kimliği)
+• Rethinking Positive Thinking (WOOP kitabı)
+• 2. el: ekspertiz, tramer, kasko teklifi
+• Ehliyet / yetki belgesi eksikse onu da takvime al</a:t>
             </a:r>
           </a:p>
         </p:txBody>
@@ -5649,10 +5649,10 @@
                 </a:solidFill>
                 <a:latin typeface="Calibri"/>
               </a:rPr>
-              <a:t>• Her gün başka koç, başka ‘anında zengin ol’ videosu
-• 10 tekniği aynı anda karıştıran listeler
-• Başkasının iradesini manipüle etme vaatleri
-• The Secret’i tek kaynak sanmak (çok genel kalır)</a:t>
+              <a:t>• ‘Evren bugün araba yollar’ reelleri
+• 10 modeli aynı anda hayal etmek
+• Marka takıntısı yüzünden 0 adım
+• Sadece hayal edip ilan / biriktirme yok</a:t>
             </a:r>
           </a:p>
         </p:txBody>
@@ -5687,7 +5687,7 @@
                 </a:solidFill>
                 <a:latin typeface="Calibri"/>
               </a:rPr>
-              <a:t>7 günde hızlı manifest  •  tek istek  •  369 + SATS + WOOP  •  her gün 1 somut adım</a:t>
+              <a:t>Kendi arabam  •  369 + SATS + WOOP  •  her gün 1 araba adımı</a:t>
             </a:r>
           </a:p>
         </p:txBody>
@@ -6179,7 +6179,7 @@
                 </a:solidFill>
                 <a:latin typeface="Calibri"/>
               </a:rPr>
-              <a:t>Tek isteği bir satıra yaz. Süzgeçten geçir.</a:t>
+              <a:t>Kilit cümleyi yaz: kendi arabamla yola çıkıyorum.</a:t>
             </a:r>
           </a:p>
         </p:txBody>
@@ -6339,7 +6339,7 @@
                 </a:solidFill>
                 <a:latin typeface="Calibri"/>
               </a:rPr>
-              <a:t>369 cümlesini yaz. Sesli oku. Vücutta sıkışma varsa yumuşat.</a:t>
+              <a:t>Bütçe alt–üst ve 2. el / yeni. En fazla 3 model.</a:t>
             </a:r>
           </a:p>
         </p:txBody>
@@ -6499,7 +6499,7 @@
                 </a:solidFill>
                 <a:latin typeface="Calibri"/>
               </a:rPr>
-              <a:t>SATS sahnesini 5 saniyeye indir. Kağıda 3 duyusal ayrıntı.</a:t>
+              <a:t>SATS: evin önü, kendi anahtarın, çevir, kemer klik.</a:t>
             </a:r>
           </a:p>
         </p:txBody>
@@ -6659,7 +6659,7 @@
                 </a:solidFill>
                 <a:latin typeface="Calibri"/>
               </a:rPr>
-              <a:t>WOOP: istek / sonuç / iç engel / eğer-o zaman.</a:t>
+              <a:t>WOOP: ‘param yetmez’ → 2 dk biriktirme veya 1 mesaj.</a:t>
             </a:r>
           </a:p>
         </p:txBody>
@@ -6819,7 +6819,7 @@
                 </a:solidFill>
                 <a:latin typeface="Calibri"/>
               </a:rPr>
-              <a:t>Bugünün 1 adımını bitir. Sonra akşam 9 yazış + SATS.</a:t>
+              <a:t>Bugün 1 ilan kaydet veya 1 fiyat sor. Akşam 9 yazış + SATS.</a:t>
             </a:r>
           </a:p>
         </p:txBody>
@@ -6934,10 +6934,10 @@
                 </a:solidFill>
                 <a:latin typeface="Calibri"/>
               </a:rPr>
-              <a:t>Bir istek.
+              <a:t>Kendi arabam.
 Aynı cümle.
-Aynı sahne.
-Her gün bir adım.
+Anahtarı çevir.
+Her gün 1 adım.
 7 gün sonra yeni teknik arama. 21 güne uzat.</a:t>
             </a:r>
           </a:p>
@@ -6973,7 +6973,7 @@
                 </a:solidFill>
                 <a:latin typeface="Calibri"/>
               </a:rPr>
-              <a:t>7 günde hızlı manifest  •  tek istek  •  369 + SATS + WOOP  •  her gün 1 somut adım</a:t>
+              <a:t>Kendi arabam  •  369 + SATS + WOOP  •  her gün 1 araba adımı</a:t>
             </a:r>
           </a:p>
         </p:txBody>
@@ -7270,7 +7270,7 @@
                 </a:solidFill>
                 <a:latin typeface="Calibri"/>
               </a:rPr>
-              <a:t>Hızlı sonuç isteyenler neyi yanlış anlıyor?</a:t>
+              <a:t>Araba ‘gelsin’ diye beklemek neden yavaştır?</a:t>
             </a:r>
           </a:p>
         </p:txBody>
@@ -7305,7 +7305,7 @@
                 </a:solidFill>
                 <a:latin typeface="Calibri"/>
               </a:rPr>
-              <a:t>Sadece hayal etmek yetmez. Hız = netlik + his + bugünkü adım.</a:t>
+              <a:t>Hız = direksiyon hissi + bugün atılan 1 araba adımı.</a:t>
             </a:r>
           </a:p>
         </p:txBody>
@@ -7420,7 +7420,7 @@
                 </a:solidFill>
                 <a:latin typeface="Calibri"/>
               </a:rPr>
-              <a:t>20 teknik birden denemek, sürekli video izlemek, ‘evren göndersin’ deyip beklemek. Zihin dağılır, istek bulanık kalır.</a:t>
+              <a:t>20 model, 20 reel, ‘birden param gelir’ diye beklemek. Zihin dağılır, araba hayali kalır.</a:t>
             </a:r>
           </a:p>
         </p:txBody>
@@ -7535,7 +7535,7 @@
                 </a:solidFill>
                 <a:latin typeface="Calibri"/>
               </a:rPr>
-              <a:t>7 gün boyunca tek istek. Aynı cümle. Aynı gece sahnesi. Her gün o isteği 10 dakikalık gerçek bir adımla ilerletmek.</a:t>
+              <a:t>7 gün sadece kendi araban. Aynı cümle. Aynı gece sahnesi. Her gün 10 dakikalık gerçek adım: bütçe, ilan, galeri, biriktirme.</a:t>
             </a:r>
           </a:p>
         </p:txBody>
@@ -7650,7 +7650,7 @@
                 </a:solidFill>
                 <a:latin typeface="Calibri"/>
               </a:rPr>
-              <a:t>Manifest bir sihir garantisi değildir. Dikkatini ve davranışını aynı yöne kilitler. Kilitlenen şey daha çabuk görünür hale gelir.</a:t>
+              <a:t>Anahtar evrene sipariş değildir. Dikkatini ve adımını arabaya kilitlersen fırsat, ilan ve cesaret daha çabuk görünür.</a:t>
             </a:r>
           </a:p>
         </p:txBody>
@@ -7765,7 +7765,7 @@
                 </a:solidFill>
                 <a:latin typeface="Calibri"/>
               </a:rPr>
-              <a:t>Neville Goddard’ın SATS’ı (uykuya yakın halde ‘oldu’ hissi) + 369 yazma (günde 18 kez aynı cümle) + WOOP (istek, sonuç, engel, eğer-o zaman planı). İlk ikisi zihni hizalar, üçüncüsü sonucu hızlandırır. Araştırmalarda tek başına pozitif hayal, eylemi bazen azaltır; WOOP ise eylemi artırır.</a:t>
+              <a:t>Neville’in SATS’ı (uykuya yakın halde direksiyonda ‘bu benim’ hissi) + 369 (günde 18 kez aynı araba cümlesi) + WOOP (para korkusu ve ertelemeyi 2 dakikalık plana bağlamak). Hayal tek başına yetmez; araba, bütçe ve bir telefonla yaklaşır.</a:t>
             </a:r>
           </a:p>
         </p:txBody>
@@ -7800,7 +7800,7 @@
                 </a:solidFill>
                 <a:latin typeface="Calibri"/>
               </a:rPr>
-              <a:t>7 günde hızlı manifest  •  tek istek  •  369 + SATS + WOOP  •  her gün 1 somut adım</a:t>
+              <a:t>Kendi arabam  •  369 + SATS + WOOP  •  her gün 1 araba adımı</a:t>
             </a:r>
           </a:p>
         </p:txBody>
@@ -8097,7 +8097,7 @@
                 </a:solidFill>
                 <a:latin typeface="Calibri"/>
               </a:rPr>
-              <a:t>7 gün boyunca sadece bir şey iste</a:t>
+              <a:t>Bu 7 günün tek isteği: kendi arabam</a:t>
             </a:r>
           </a:p>
         </p:txBody>
@@ -8132,7 +8132,7 @@
                 </a:solidFill>
                 <a:latin typeface="Calibri"/>
               </a:rPr>
-              <a:t>Birden fazla dilek = hiçbirinin enerjisi yetmez. Önce bir tanesini bitir.</a:t>
+              <a:t>Ev, iş, ilişki yok. Sadece araba. Model savaşını da 3 adaya indir.</a:t>
             </a:r>
           </a:p>
         </p:txBody>
@@ -8247,9 +8247,9 @@
                 </a:solidFill>
                 <a:latin typeface="Calibri"/>
               </a:rPr>
-              <a:t>Şablon:
-“Çok minnettarım, [somut sonuç] artık hayatımda ve kendimi [duygu] hissediyorum.”
-Şimdi zamanı. “İstiyorum / olacak” yok. Olumsuz yok. Rakam varsa yaz.</a:t>
+              <a:t>Senin kilit cümlen:
+“Çok minnettarım, kendi arabamla yola çıkıyorum ve özgür hissediyorum.”
+Şimdi zamanı. ‘İstiyorum / olacak’ yok. Marka takıntısı yok; his ‘kendi arabam’.</a:t>
             </a:r>
           </a:p>
         </p:txBody>
@@ -8364,7 +8364,7 @@
                 </a:solidFill>
                 <a:latin typeface="Calibri"/>
               </a:rPr>
-              <a:t>Bol para istiyorum, stresim bitsin.</a:t>
+              <a:t>Araba istiyorum, bir an önce olsun.</a:t>
             </a:r>
           </a:p>
         </p:txBody>
@@ -8479,7 +8479,7 @@
                 </a:solidFill>
                 <a:latin typeface="Calibri"/>
               </a:rPr>
-              <a:t>Çok minnettarım, bu ay faturalarım rahat ödeniyor ve kendimi güvende hissediyorum.</a:t>
+              <a:t>Çok minnettarım, kendi arabamla yola çıkıyorum ve özgür hissediyorum.</a:t>
             </a:r>
           </a:p>
         </p:txBody>
@@ -8594,7 +8594,7 @@
                 </a:solidFill>
                 <a:latin typeface="Calibri"/>
               </a:rPr>
-              <a:t>O beni özlesin, yazsın.</a:t>
+              <a:t>Param yetmez, belki biri alır.</a:t>
             </a:r>
           </a:p>
         </p:txBody>
@@ -8709,7 +8709,7 @@
                 </a:solidFill>
                 <a:latin typeface="Calibri"/>
               </a:rPr>
-              <a:t>Sakin ve seçilmiş hissediyorum; karşılıklı, net bir bağ içindeyim.</a:t>
+              <a:t>Kendi arabamın anahtarı çantamda; her yere rahatça gidiyorum.</a:t>
             </a:r>
           </a:p>
         </p:txBody>
@@ -8902,7 +8902,7 @@
                 </a:solidFill>
                 <a:latin typeface="Calibri"/>
               </a:rPr>
-              <a:t>90 gün içinde mümkün mü?</a:t>
+              <a:t>90 günde peşinat / kredi / 2. el mümkün mü?</a:t>
             </a:r>
           </a:p>
         </p:txBody>
@@ -9015,7 +9015,7 @@
                 </a:solidFill>
                 <a:latin typeface="Calibri"/>
               </a:rPr>
-              <a:t>Olduğunu hayal edince vücutta bir yumuşama var mı?</a:t>
+              <a:t>Direksiyonda hayal edince vücut yumuşuyor mu?</a:t>
             </a:r>
           </a:p>
         </p:txBody>
@@ -9128,7 +9128,7 @@
                 </a:solidFill>
                 <a:latin typeface="Calibri"/>
               </a:rPr>
-              <a:t>Senin atabileceğin en az bir adım var mı?</a:t>
+              <a:t>Bugün atabileceğin 1 araba adımı var mı?</a:t>
             </a:r>
           </a:p>
         </p:txBody>
@@ -9241,7 +9241,7 @@
                 </a:solidFill>
                 <a:latin typeface="Calibri"/>
               </a:rPr>
-              <a:t>Başkasının iradesini zorlamıyor mu?</a:t>
+              <a:t>Başkasının sana araba almasını dayatmıyor musun?</a:t>
             </a:r>
           </a:p>
         </p:txBody>
@@ -9354,7 +9354,7 @@
                 </a:solidFill>
                 <a:latin typeface="Calibri"/>
               </a:rPr>
-              <a:t>Ölçülebilir mi? (tarih, tutar, olay)</a:t>
+              <a:t>Ölçülebilir mi? (bütçe aralığı, 2. el / yeni)</a:t>
             </a:r>
           </a:p>
         </p:txBody>
@@ -9389,7 +9389,7 @@
                 </a:solidFill>
                 <a:latin typeface="Calibri"/>
               </a:rPr>
-              <a:t>7 günde hızlı manifest  •  tek istek  •  369 + SATS + WOOP  •  her gün 1 somut adım</a:t>
+              <a:t>Kendi arabam  •  369 + SATS + WOOP  •  her gün 1 araba adımı</a:t>
             </a:r>
           </a:p>
         </p:txBody>
@@ -9916,7 +9916,7 @@
                 </a:solidFill>
                 <a:latin typeface="Calibri"/>
               </a:rPr>
-              <a:t>Uyanır uyanmaz 369 cümlenı 3 kez elle yaz. Bitince 10 saniye gözün kapalı, ‘oldu’ hissini al.</a:t>
+              <a:t>Uyanır uyanmaz araba cümlenı 3 kez elle yaz. Bitince 10 saniye: anahtar elde, direksiyonda ‘bu benim’.</a:t>
             </a:r>
           </a:p>
         </p:txBody>
@@ -10111,7 +10111,7 @@
                 </a:solidFill>
                 <a:latin typeface="Calibri"/>
               </a:rPr>
-              <a:t>WOOP’taki eğer-o zaman planını çalıştır. Bugünün tek somut adımını bitirmeden telefonu açma.</a:t>
+              <a:t>Bugünün araba adımını bitir: bütçe, ilan, galeri, sigorta veya biriktirme. Bitirmeden kaydırma.</a:t>
             </a:r>
           </a:p>
         </p:txBody>
@@ -10306,7 +10306,7 @@
                 </a:solidFill>
                 <a:latin typeface="Calibri"/>
               </a:rPr>
-              <a:t>Aynı cümleyi 6 kez yaz. Şüphe gelirse cümleyi tartışma; yaz ve kapat.</a:t>
+              <a:t>Aynı cümleyi 6 kez yaz. ‘Param yetmez’ gelirse yaz ve kapat; cümleyi tartışma.</a:t>
             </a:r>
           </a:p>
         </p:txBody>
@@ -10501,7 +10501,7 @@
                 </a:solidFill>
                 <a:latin typeface="Calibri"/>
               </a:rPr>
-              <a:t>Cümleyi 9 kez yaz. Yatağa gir. SATS sahnesini 5–10 saniyelik döngüde uykuya kadar tekrarla.</a:t>
+              <a:t>Cümleyi 9 kez yaz. Yatağa gir. Anahtarı çevirdiğin 5 saniyelik sahneyi uykuya kadar döngüle.</a:t>
             </a:r>
           </a:p>
         </p:txBody>
@@ -10536,7 +10536,7 @@
                 </a:solidFill>
                 <a:latin typeface="Calibri"/>
               </a:rPr>
-              <a:t>7 günde hızlı manifest  •  tek istek  •  369 + SATS + WOOP  •  her gün 1 somut adım</a:t>
+              <a:t>Kendi arabam  •  369 + SATS + WOOP  •  her gün 1 araba adımı</a:t>
             </a:r>
           </a:p>
         </p:txBody>
@@ -10983,9 +10983,9 @@
                 </a:solidFill>
                 <a:latin typeface="Calibri"/>
               </a:rPr>
-              <a:t>Yataktan kalkınca, telefonu eline almadan.
-Amaç: günün ilk izi ‘oldu’ olsun.
-Yazarken acele etme. Her satırda nefes al, minnettarlığı bir saniye hisset.</a:t>
+              <a:t>Yataktan kalkınca, ilan sitesini açmadan.
+Amaç: günün ilk izi ‘kendi arabam’ olsun.
+Her satırda 1 saniye direksiyon hissi: elin simitte, omuzlar düşük.</a:t>
             </a:r>
           </a:p>
         </p:txBody>
@@ -11100,8 +11100,8 @@
                 </a:solidFill>
                 <a:latin typeface="Calibri"/>
               </a:rPr>
-              <a:t>Günün ortasında zihin dağılır. 6 tekrar onu geri çağırır.
-Şüphe gelirse yandaki sayfaya 1 cümle yaz: “Nasıl olacağını bilmiyorum, yine de oldu.” Sonra 369’a dön.</a:t>
+              <a:t>Günün ortasında ‘alamam’ gelir. 6 tekrar onu geri çağırır.
+Şüphe gelirse bir satır yaz: “Nasıl olacağını bilmiyorum, anahtar yine de benim.” Sonra 369’a dön.</a:t>
             </a:r>
           </a:p>
         </p:txBody>
@@ -11217,7 +11217,7 @@
                 <a:latin typeface="Calibri"/>
               </a:rPr>
               <a:t>Uyumadan 30 dakika içinde bitir.
-9. satırdan sonra defteri kapat. Kanıt ara, mesaj kontrol etme, ‘çalıştı mı’ diye evrene bakma. Hemen SATS’a geç.</a:t>
+9. satırdan sonra ilan bakma. Defteri kapat. Hemen SATS: evin önünde park, anahtarı çevir, ‘geldik’.</a:t>
             </a:r>
           </a:p>
         </p:txBody>
@@ -11252,7 +11252,7 @@
                 </a:solidFill>
                 <a:latin typeface="Calibri"/>
               </a:rPr>
-              <a:t>7 günde hızlı manifest  •  tek istek  •  369 + SATS + WOOP  •  her gün 1 somut adım</a:t>
+              <a:t>Kendi arabam  •  369 + SATS + WOOP  •  her gün 1 araba adımı</a:t>
             </a:r>
           </a:p>
         </p:txBody>
@@ -11968,7 +11968,7 @@
                 </a:solidFill>
                 <a:latin typeface="Calibri"/>
               </a:rPr>
-              <a:t>5 duyu: ne gördün, ne duydun, vücutta ne vardı?</a:t>
+              <a:t>5 duyu: koku, kumaş, motor sesi, simidin ısısı.</a:t>
             </a:r>
           </a:p>
         </p:txBody>
@@ -12081,7 +12081,7 @@
                 </a:solidFill>
                 <a:latin typeface="Calibri"/>
               </a:rPr>
-              <a:t>Küçük ayrıntı: kupa, ışık, bir cümle, bir imza.</a:t>
+              <a:t>Küçük ayrıntı: anahtarlık, ruhsat, park yeri, emniyet kemeri klik.</a:t>
             </a:r>
           </a:p>
         </p:txBody>
@@ -12194,7 +12194,7 @@
                 </a:solidFill>
                 <a:latin typeface="Calibri"/>
               </a:rPr>
-              <a:t>Duygu: rahatlama, sıradanlık, ‘tabii ki böyle’.</a:t>
+              <a:t>Duygu: rahatlama, sıradanlık, ‘tabii ki benim arabam’.</a:t>
             </a:r>
           </a:p>
         </p:txBody>
@@ -12422,7 +12422,7 @@
                 </a:solidFill>
                 <a:latin typeface="Calibri"/>
               </a:rPr>
-              <a:t>“Salı sabahı masamda kahvemi içiyorum. Mail kutusunda onay var. Omuzlarım düşük, nefesim rahat. Anneme ‘oldu’ diye yazıyorum. Teşekkür ederim, bu artık normalim.”</a:t>
+              <a:t>“Salı sabahı kendi arabamın kapısını açıyorum. Koltuk bana göre. Anahtarı çeviriyorum, motor tok çalışıyor. Evin önünden çıkıp yola karışıyorum. Teşekkür ederim, bu artık normalim.”</a:t>
             </a:r>
           </a:p>
         </p:txBody>
@@ -12457,7 +12457,7 @@
                 </a:solidFill>
                 <a:latin typeface="Calibri"/>
               </a:rPr>
-              <a:t>7 günde hızlı manifest  •  tek istek  •  369 + SATS + WOOP  •  her gün 1 somut adım</a:t>
+              <a:t>Kendi arabam  •  369 + SATS + WOOP  •  her gün 1 araba adımı</a:t>
             </a:r>
           </a:p>
         </p:txBody>
@@ -12982,7 +12982,7 @@
                 </a:solidFill>
                 <a:latin typeface="Calibri"/>
               </a:rPr>
-              <a:t>El sıkışma, anahtar çevirme, ‘tebrikler’ cümlesi, hesap bakiyesini görme. 5–10 saniye. Birinci tekil şahıs.</a:t>
+              <a:t>Evin önünde park. Çantadan kendi anahtarın. Sürücü koltuğu. Anahtarı çevir. 5–10 saniye. Birinci tekil şahıs.</a:t>
             </a:r>
           </a:p>
         </p:txBody>
@@ -13596,7 +13596,7 @@
                 </a:solidFill>
                 <a:latin typeface="Calibri"/>
               </a:rPr>
-              <a:t>7 günde hızlı manifest  •  tek istek  •  369 + SATS + WOOP  •  her gün 1 somut adım</a:t>
+              <a:t>Kendi arabam  •  369 + SATS + WOOP  •  her gün 1 araba adımı</a:t>
             </a:r>
           </a:p>
         </p:txBody>
@@ -14121,7 +14121,7 @@
                 </a:solidFill>
                 <a:latin typeface="Calibri"/>
               </a:rPr>
-              <a:t>Tek, net, senin için zor ama mümkün dilek. 3-6-9 cümlenle aynı olsun.</a:t>
+              <a:t>Kendi arabam. 369 cümlenle aynı olsun. Marka savaşını 3 adaya bırak.</a:t>
             </a:r>
           </a:p>
         </p:txBody>
@@ -14314,7 +14314,7 @@
                 </a:solidFill>
                 <a:latin typeface="Calibri"/>
               </a:rPr>
-              <a:t>Olduğunda en güzel an. 30 saniye gözün kapalı yaşa. Göğüste ne açılıyor?</a:t>
+              <a:t>Kapıyı açıp koltuğa oturduğun an. Kemer klik. ‘Geldik’ hissi göğüste.</a:t>
             </a:r>
           </a:p>
         </p:txBody>
@@ -14507,7 +14507,7 @@
                 </a:solidFill>
                 <a:latin typeface="Calibri"/>
               </a:rPr>
-              <a:t>Dış dünya değil, içindeki asıl fren: erteleme, utanç, ‘hak etmiyorum’, gece telefon.</a:t>
+              <a:t>Dış fiyat değil: ‘param yetmez’ kaydırması, ilanlara bakıp hiçbirini aramamak.</a:t>
             </a:r>
           </a:p>
         </p:txBody>
@@ -14700,7 +14700,7 @@
                 </a:solidFill>
                 <a:latin typeface="Calibri"/>
               </a:rPr>
-              <a:t>Eğer [engel belirirse], o zaman [2 dakikalık davranış]. Önceden yaz, karar anında düşünme.</a:t>
+              <a:t>Eğer ‘alamam’ gelirse, o zaman 2 dk: biriktirme notu veya 1 ilan mesajı.</a:t>
             </a:r>
           </a:p>
         </p:txBody>
@@ -14815,7 +14815,7 @@
                 </a:solidFill>
                 <a:latin typeface="Calibri"/>
               </a:rPr>
-              <a:t>Eğer öğleden sonra ‘nasıl olsa olmaz’ diye kaydırırsam, o zaman telefonu başka odaya koyar, 2 dakikalık adımı (mail / arama / dosya / fiyat) hemen bitiririm.</a:t>
+              <a:t>Eğer öğleden sonra ‘nasıl olsa araba alamam’ diye kaydırırsam, o zaman telefonu bırakır, bütçe satırını doldurur veya 1 satıcıya mesaj atarım.</a:t>
             </a:r>
           </a:p>
         </p:txBody>
@@ -14850,7 +14850,7 @@
                 </a:solidFill>
                 <a:latin typeface="Calibri"/>
               </a:rPr>
-              <a:t>7 günde hızlı manifest  •  tek istek  •  369 + SATS + WOOP  •  her gün 1 somut adım</a:t>
+              <a:t>Kendi arabam  •  369 + SATS + WOOP  •  her gün 1 araba adımı</a:t>
             </a:r>
           </a:p>
         </p:txBody>
@@ -15147,7 +15147,7 @@
                 </a:solidFill>
                 <a:latin typeface="Calibri"/>
               </a:rPr>
-              <a:t>7 günlük hız protokolü</a:t>
+              <a:t>7 günde arabaya yaklaş</a:t>
             </a:r>
           </a:p>
         </p:txBody>
@@ -15182,7 +15182,7 @@
                 </a:solidFill>
                 <a:latin typeface="Calibri"/>
               </a:rPr>
-              <a:t>Her gün: 369 + SATS + 1 adım. Tema değişir, sistem değişmez.</a:t>
+              <a:t>Her gün: 369 + SATS + 1 araba adımı. Tema değişir, sistem değişmez.</a:t>
             </a:r>
           </a:p>
         </p:txBody>
@@ -15375,7 +15375,7 @@
                 </a:solidFill>
                 <a:latin typeface="Calibri"/>
               </a:rPr>
-              <a:t>Tek istek, 369 cümlesi, SATS sahnesi, WOOP. İlk somut adım bugün atılır.</a:t>
+              <a:t>Cümle + SATS sahnesi. Bütçe aralığı ve 2. el / yeni kararı. En fazla 3 model.</a:t>
             </a:r>
           </a:p>
         </p:txBody>
@@ -15568,7 +15568,7 @@
                 </a:solidFill>
                 <a:latin typeface="Calibri"/>
               </a:rPr>
-              <a:t>Aynı cümle. En küçük görünür hareket: bir mesaj, bir dosya, bir fiyat, bir yürüyüş.</a:t>
+              <a:t>Aynı cümle. Ehliyet, trafik sigortası, kasko için kaba fiyat. Biriktirme hesabı aç veya ayır.</a:t>
             </a:r>
           </a:p>
         </p:txBody>
@@ -15761,7 +15761,7 @@
                 </a:solidFill>
                 <a:latin typeface="Calibri"/>
               </a:rPr>
-              <a:t>8 dakikalık scripting. Bir insanla konuş veya bir kapı çal.</a:t>
+              <a:t>8 dk scripting: salı sabahı kendi araban. 5 ilan kaydet, 2’sini yaz.</a:t>
             </a:r>
           </a:p>
         </p:txBody>
@@ -15954,7 +15954,7 @@
                 </a:solidFill>
                 <a:latin typeface="Calibri"/>
               </a:rPr>
-              <a:t>WOOP’u yeniden yaz. Asıl iç freni adlandır. Eğer-o zaman planını sıkılaştır.</a:t>
+              <a:t>‘Param yetmez’i adlandır. İlk küçük transferi yap. WOOP planını sıkılaştır.</a:t>
             </a:r>
           </a:p>
         </p:txBody>
@@ -16147,7 +16147,7 @@
                 </a:solidFill>
                 <a:latin typeface="Calibri"/>
               </a:rPr>
-              <a:t>Günü ‘bunu zaten yaşayan kişi’ olarak geçir. Kıyafet, masa, konuşma tonu uyumlu olsun.</a:t>
+              <a:t>Galeride benzer bir arabaya otur veya park yerinden geç. ‘Zaten sürücüyüm’ günü.</a:t>
             </a:r>
           </a:p>
         </p:txBody>
@@ -16340,7 +16340,7 @@
                 </a:solidFill>
                 <a:latin typeface="Calibri"/>
               </a:rPr>
-              <a:t>3 küçük işaret not et (zorlama). Bir büyükçe adım: başvuru, teklif, ödeme, bitirme.</a:t>
+              <a:t>1 satıcı / galeri ara. 1 ekspertiz veya fiyat sor. 3 küçük işaret not et.</a:t>
             </a:r>
           </a:p>
         </p:txBody>
@@ -16533,7 +16533,7 @@
                 </a:solidFill>
                 <a:latin typeface="Calibri"/>
               </a:rPr>
-              <a:t>7 günü oku. Cümleyi gerekirse %10 netleştir. Önündeki 21 güne kilit at. Kontrolü bırak.</a:t>
+              <a:t>3 adayı 1–2’ye indir. 21 güne kilit: her hafta 1 bakış + her hafta 1 biriktirme.</a:t>
             </a:r>
           </a:p>
         </p:txBody>
@@ -16568,7 +16568,7 @@
                 </a:solidFill>
                 <a:latin typeface="Calibri"/>
               </a:rPr>
-              <a:t>7 günde hızlı manifest  •  tek istek  •  369 + SATS + WOOP  •  her gün 1 somut adım</a:t>
+              <a:t>Kendi arabam  •  369 + SATS + WOOP  •  her gün 1 araba adımı</a:t>
             </a:r>
           </a:p>
         </p:txBody>

</xml_diff>